<commit_message>
Slides: sd-13-004 slide 8 says static_configs is updated by hand
Re-exported badged PPTX after correcting the slide to match the lesson.

Co-Authored-By: Claude Opus 5.5 <noreply@anthropic.com>
Claude-Session: https://claude.ai/code/session_01TQmrJYLm4GPgtXpQaEk7ey
</commit_message>
<xml_diff>
--- a/system-design-101/vi/lessons/sd-13-004/slides/sd-13-004.pptx
+++ b/system-design-101/vi/lessons/sd-13-004/slides/sd-13-004.pptx
@@ -11184,15 +11184,26 @@
               <a:t>static_configs:</a:t>
             </a:r>
             <a:r>
-              <a:rPr lang="en-US" sz="2400" dirty="0" spc="4" kern="0">
-                <a:solidFill>
-                  <a:srgbClr val="14161C"/>
-                </a:solidFill>
-                <a:latin typeface="Be Vietnam Pro" pitchFamily="34" charset="0"/>
-                <a:ea typeface="Be Vietnam Pro" pitchFamily="34" charset="-122"/>
-                <a:cs typeface="Be Vietnam Pro" pitchFamily="34" charset="-120"/>
-              </a:rPr>
-              <a:t> tự</a:t>
+              <a:rPr lang="en-US" sz="2400" dirty="0" spc="7" kern="0">
+                <a:solidFill>
+                  <a:srgbClr val="14161C"/>
+                </a:solidFill>
+                <a:latin typeface="Be Vietnam Pro" pitchFamily="34" charset="0"/>
+                <a:ea typeface="Be Vietnam Pro" pitchFamily="34" charset="-122"/>
+                <a:cs typeface="Be Vietnam Pro" pitchFamily="34" charset="-120"/>
+              </a:rPr>
+              <a:t> người</a:t>
+            </a:r>
+            <a:r>
+              <a:rPr lang="en-US" sz="2400" dirty="0" spc="-12" kern="0">
+                <a:solidFill>
+                  <a:srgbClr val="14161C"/>
+                </a:solidFill>
+                <a:latin typeface="Be Vietnam Pro" pitchFamily="34" charset="0"/>
+                <a:ea typeface="Be Vietnam Pro" pitchFamily="34" charset="-122"/>
+                <a:cs typeface="Be Vietnam Pro" pitchFamily="34" charset="-120"/>
+              </a:rPr>
+              <a:t> vận</a:t>
             </a:r>
             <a:r>
               <a:rPr lang="en-US" sz="2400" dirty="0" spc="1" kern="0">
@@ -11203,7 +11214,7 @@
                 <a:ea typeface="Be Vietnam Pro" pitchFamily="34" charset="-122"/>
                 <a:cs typeface="Be Vietnam Pro" pitchFamily="34" charset="-120"/>
               </a:rPr>
-              <a:t> cập</a:t>
+              <a:t> hành cập</a:t>
             </a:r>
             <a:r>
               <a:rPr lang="en-US" sz="2400" dirty="0" spc="-8" kern="0">
@@ -11217,37 +11228,15 @@
               <a:t> nhật</a:t>
             </a:r>
             <a:r>
-              <a:rPr lang="en-US" sz="2400" dirty="0" spc="2" kern="0">
-                <a:solidFill>
-                  <a:srgbClr val="14161C"/>
-                </a:solidFill>
-                <a:latin typeface="Be Vietnam Pro" pitchFamily="34" charset="0"/>
-                <a:ea typeface="Be Vietnam Pro" pitchFamily="34" charset="-122"/>
-                <a:cs typeface="Be Vietnam Pro" pitchFamily="34" charset="-120"/>
-              </a:rPr>
-              <a:t> danh</a:t>
-            </a:r>
-            <a:r>
-              <a:rPr lang="en-US" sz="2400" dirty="0" spc="-6" kern="0">
-                <a:solidFill>
-                  <a:srgbClr val="14161C"/>
-                </a:solidFill>
-                <a:latin typeface="Be Vietnam Pro" pitchFamily="34" charset="0"/>
-                <a:ea typeface="Be Vietnam Pro" pitchFamily="34" charset="-122"/>
-                <a:cs typeface="Be Vietnam Pro" pitchFamily="34" charset="-120"/>
-              </a:rPr>
-              <a:t> sách</a:t>
-            </a:r>
-            <a:r>
-              <a:rPr lang="en-US" sz="2400" dirty="0" spc="16" kern="0">
-                <a:solidFill>
-                  <a:srgbClr val="14161C"/>
-                </a:solidFill>
-                <a:latin typeface="Be Vietnam Pro" pitchFamily="34" charset="0"/>
-                <a:ea typeface="Be Vietnam Pro" pitchFamily="34" charset="-122"/>
-                <a:cs typeface="Be Vietnam Pro" pitchFamily="34" charset="-120"/>
-              </a:rPr>
-              <a:t> đích.</a:t>
+              <a:rPr lang="en-US" sz="2400" dirty="0" spc="-16" kern="0">
+                <a:solidFill>
+                  <a:srgbClr val="14161C"/>
+                </a:solidFill>
+                <a:latin typeface="Be Vietnam Pro" pitchFamily="34" charset="0"/>
+                <a:ea typeface="Be Vietnam Pro" pitchFamily="34" charset="-122"/>
+                <a:cs typeface="Be Vietnam Pro" pitchFamily="34" charset="-120"/>
+              </a:rPr>
+              <a:t> tay.</a:t>
             </a:r>
             <a:endParaRPr lang="en-US" sz="2400" dirty="0"/>
           </a:p>
@@ -11261,40 +11250,51 @@
               <a:buChar char="•"/>
             </a:pPr>
             <a:r>
+              <a:rPr lang="en-US" sz="2400" dirty="0" spc="-1" kern="0">
+                <a:solidFill>
+                  <a:srgbClr val="14161C"/>
+                </a:solidFill>
+                <a:latin typeface="Be Vietnam Pro" pitchFamily="34" charset="0"/>
+                <a:ea typeface="Be Vietnam Pro" pitchFamily="34" charset="-122"/>
+                <a:cs typeface="Be Vietnam Pro" pitchFamily="34" charset="-120"/>
+              </a:rPr>
+              <a:t>Service</a:t>
+            </a:r>
+            <a:r>
+              <a:rPr lang="en-US" sz="2400" dirty="0" spc="-13" kern="0">
+                <a:solidFill>
+                  <a:srgbClr val="14161C"/>
+                </a:solidFill>
+                <a:latin typeface="Be Vietnam Pro" pitchFamily="34" charset="0"/>
+                <a:ea typeface="Be Vietnam Pro" pitchFamily="34" charset="-122"/>
+                <a:cs typeface="Be Vietnam Pro" pitchFamily="34" charset="-120"/>
+              </a:rPr>
+              <a:t> discovery</a:t>
+            </a:r>
+            <a:r>
+              <a:rPr lang="en-US" sz="2400" dirty="0" spc="-1" kern="0">
+                <a:solidFill>
+                  <a:srgbClr val="14161C"/>
+                </a:solidFill>
+                <a:latin typeface="Be Vietnam Pro" pitchFamily="34" charset="0"/>
+                <a:ea typeface="Be Vietnam Pro" pitchFamily="34" charset="-122"/>
+                <a:cs typeface="Be Vietnam Pro" pitchFamily="34" charset="-120"/>
+              </a:rPr>
+              <a:t> theo</a:t>
+            </a:r>
+            <a:r>
+              <a:rPr lang="en-US" sz="2400" dirty="0" spc="0" kern="0">
+                <a:solidFill>
+                  <a:srgbClr val="14161C"/>
+                </a:solidFill>
+                <a:latin typeface="Be Vietnam Pro" pitchFamily="34" charset="0"/>
+                <a:ea typeface="Be Vietnam Pro" pitchFamily="34" charset="-122"/>
+                <a:cs typeface="Be Vietnam Pro" pitchFamily="34" charset="-120"/>
+              </a:rPr>
+              <a:t> kịp,</a:t>
+            </a:r>
+            <a:r>
               <a:rPr lang="en-US" sz="2400" dirty="0" spc="-2" kern="0">
-                <a:solidFill>
-                  <a:srgbClr val="14161C"/>
-                </a:solidFill>
-                <a:latin typeface="Be Vietnam Pro" pitchFamily="34" charset="0"/>
-                <a:ea typeface="Be Vietnam Pro" pitchFamily="34" charset="-122"/>
-                <a:cs typeface="Be Vietnam Pro" pitchFamily="34" charset="-120"/>
-              </a:rPr>
-              <a:t>Hoặc</a:t>
-            </a:r>
-            <a:r>
-              <a:rPr lang="en-US" sz="2400" dirty="0" spc="-4" kern="0">
-                <a:solidFill>
-                  <a:srgbClr val="14161C"/>
-                </a:solidFill>
-                <a:latin typeface="Be Vietnam Pro" pitchFamily="34" charset="0"/>
-                <a:ea typeface="Be Vietnam Pro" pitchFamily="34" charset="-122"/>
-                <a:cs typeface="Be Vietnam Pro" pitchFamily="34" charset="-120"/>
-              </a:rPr>
-              <a:t> service</a:t>
-            </a:r>
-            <a:r>
-              <a:rPr lang="en-US" sz="2400" dirty="0" spc="-12" kern="0">
-                <a:solidFill>
-                  <a:srgbClr val="14161C"/>
-                </a:solidFill>
-                <a:latin typeface="Be Vietnam Pro" pitchFamily="34" charset="0"/>
-                <a:ea typeface="Be Vietnam Pro" pitchFamily="34" charset="-122"/>
-                <a:cs typeface="Be Vietnam Pro" pitchFamily="34" charset="-120"/>
-              </a:rPr>
-              <a:t> discovery,</a:t>
-            </a:r>
-            <a:r>
-              <a:rPr lang="en-US" sz="2400" dirty="0" spc="-1" kern="0">
                 <a:solidFill>
                   <a:srgbClr val="14161C"/>
                 </a:solidFill>

</xml_diff>

<commit_message>
Slides: sd-13-004..008 titles at 92/108 and the DevOps và CI/CD group on the cover
Co-Authored-By: Claude Opus 5.5 <noreply@anthropic.com>
Claude-Session: https://claude.ai/code/session_01TQmrJYLm4GPgtXpQaEk7ey
</commit_message>
<xml_diff>
--- a/system-design-101/vi/lessons/sd-13-004/slides/sd-13-004.pptx
+++ b/system-design-101/vi/lessons/sd-13-004/slides/sd-13-004.pptx
@@ -2137,7 +2137,7 @@
               <a:t> nhóm</a:t>
             </a:r>
             <a:r>
-              <a:rPr lang="en-US" sz="1650" dirty="0" spc="-3" kern="0">
+              <a:rPr lang="en-US" sz="1650" dirty="0" spc="-4" kern="0">
                 <a:solidFill>
                   <a:srgbClr val="9AA0B5"/>
                 </a:solidFill>
@@ -2145,10 +2145,10 @@
                 <a:ea typeface="Be Vietnam Pro" pitchFamily="34" charset="-122"/>
                 <a:cs typeface="Be Vietnam Pro" pitchFamily="34" charset="-120"/>
               </a:rPr>
-              <a:t> Quan</a:t>
-            </a:r>
-            <a:r>
-              <a:rPr lang="en-US" sz="1650" dirty="0" spc="-9" kern="0">
+              <a:t> DevOps</a:t>
+            </a:r>
+            <a:r>
+              <a:rPr lang="en-US" sz="1650" dirty="0" spc="-7" kern="0">
                 <a:solidFill>
                   <a:srgbClr val="9AA0B5"/>
                 </a:solidFill>
@@ -2156,7 +2156,7 @@
                 <a:ea typeface="Be Vietnam Pro" pitchFamily="34" charset="-122"/>
                 <a:cs typeface="Be Vietnam Pro" pitchFamily="34" charset="-120"/>
               </a:rPr>
-              <a:t> sát</a:t>
+              <a:t> và</a:t>
             </a:r>
             <a:r>
               <a:rPr lang="en-US" sz="1650" dirty="0" spc="3" kern="0">
@@ -2167,18 +2167,7 @@
                 <a:ea typeface="Be Vietnam Pro" pitchFamily="34" charset="-122"/>
                 <a:cs typeface="Be Vietnam Pro" pitchFamily="34" charset="-120"/>
               </a:rPr>
-              <a:t> hệ</a:t>
-            </a:r>
-            <a:r>
-              <a:rPr lang="en-US" sz="1650" dirty="0" spc="1" kern="0">
-                <a:solidFill>
-                  <a:srgbClr val="9AA0B5"/>
-                </a:solidFill>
-                <a:latin typeface="Be Vietnam Pro" pitchFamily="34" charset="0"/>
-                <a:ea typeface="Be Vietnam Pro" pitchFamily="34" charset="-122"/>
-                <a:cs typeface="Be Vietnam Pro" pitchFamily="34" charset="-120"/>
-              </a:rPr>
-              <a:t> thống</a:t>
+              <a:t> CI/CD</a:t>
             </a:r>
             <a:endParaRPr lang="en-US" sz="1650" dirty="0"/>
           </a:p>

</xml_diff>

<commit_message>
Slides: sd-13-004..008 body text at 34 px
Co-Authored-By: Claude Opus 5.5 <noreply@anthropic.com>
Claude-Session: https://claude.ai/code/session_01TQmrJYLm4GPgtXpQaEk7ey
</commit_message>
<xml_diff>
--- a/system-design-101/vi/lessons/sd-13-004/slides/sd-13-004.pptx
+++ b/system-design-101/vi/lessons/sd-13-004/slides/sd-13-004.pptx
@@ -6142,7 +6142,7 @@
               <a:buNone/>
             </a:pPr>
             <a:r>
-              <a:rPr lang="en-US" sz="2250" b="1" dirty="0" spc="-1" kern="0">
+              <a:rPr lang="en-US" sz="2550" b="1" dirty="0" spc="2" kern="0">
                 <a:solidFill>
                   <a:srgbClr val="F3EEE3"/>
                 </a:solidFill>
@@ -6153,7 +6153,7 @@
               <a:t>1.</a:t>
             </a:r>
             <a:r>
-              <a:rPr lang="en-US" sz="2250" b="1" dirty="0" spc="-3" kern="0">
+              <a:rPr lang="en-US" sz="2550" b="1" dirty="0" spc="-8" kern="0">
                 <a:solidFill>
                   <a:srgbClr val="F3EEE3"/>
                 </a:solidFill>
@@ -6164,7 +6164,7 @@
               <a:t> Đẩy</a:t>
             </a:r>
             <a:r>
-              <a:rPr lang="en-US" sz="2250" b="1" dirty="0" spc="0" kern="0">
+              <a:rPr lang="en-US" sz="2550" b="1" dirty="0" spc="-5" kern="0">
                 <a:solidFill>
                   <a:srgbClr val="F3EEE3"/>
                 </a:solidFill>
@@ -6175,7 +6175,7 @@
               <a:t> số</a:t>
             </a:r>
             <a:r>
-              <a:rPr lang="en-US" sz="2250" b="1" dirty="0" spc="10" kern="0">
+              <a:rPr lang="en-US" sz="2550" b="1" dirty="0" spc="6" kern="0">
                 <a:solidFill>
                   <a:srgbClr val="F3EEE3"/>
                 </a:solidFill>
@@ -6186,7 +6186,7 @@
               <a:t> đo</a:t>
             </a:r>
             <a:r>
-              <a:rPr lang="en-US" sz="2250" b="1" dirty="0" spc="-7" kern="0">
+              <a:rPr lang="en-US" sz="2550" b="1" dirty="0" spc="-9" kern="0">
                 <a:solidFill>
                   <a:srgbClr val="F3EEE3"/>
                 </a:solidFill>
@@ -6196,7 +6196,7 @@
               </a:rPr>
               <a:t> lên</a:t>
             </a:r>
-            <a:endParaRPr lang="en-US" sz="2250" dirty="0"/>
+            <a:endParaRPr lang="en-US" sz="2550" dirty="0"/>
           </a:p>
         </p:txBody>
       </p:sp>
@@ -6331,7 +6331,7 @@
               <a:buNone/>
             </a:pPr>
             <a:r>
-              <a:rPr lang="en-US" sz="2250" b="1" dirty="0" spc="-1" kern="0">
+              <a:rPr lang="en-US" sz="2550" b="1" dirty="0" spc="5" kern="0">
                 <a:solidFill>
                   <a:srgbClr val="F3EEE3"/>
                 </a:solidFill>
@@ -6342,7 +6342,7 @@
               <a:t>2.</a:t>
             </a:r>
             <a:r>
-              <a:rPr lang="en-US" sz="2250" b="1" dirty="0" spc="-8" kern="0">
+              <a:rPr lang="en-US" sz="2550" b="1" dirty="0" spc="-13" kern="0">
                 <a:solidFill>
                   <a:srgbClr val="F3EEE3"/>
                 </a:solidFill>
@@ -6353,7 +6353,7 @@
               <a:t> Prometheus</a:t>
             </a:r>
             <a:r>
-              <a:rPr lang="en-US" sz="2250" b="1" dirty="0" spc="-22" kern="0">
+              <a:rPr lang="en-US" sz="2550" b="1" dirty="0" spc="-26" kern="0">
                 <a:solidFill>
                   <a:srgbClr val="F3EEE3"/>
                 </a:solidFill>
@@ -6364,7 +6364,7 @@
               <a:t> kéo</a:t>
             </a:r>
             <a:r>
-              <a:rPr lang="en-US" sz="2250" b="1" dirty="0" spc="1" kern="0">
+              <a:rPr lang="en-US" sz="2550" b="1" dirty="0" spc="-1" kern="0">
                 <a:solidFill>
                   <a:srgbClr val="F3EEE3"/>
                 </a:solidFill>
@@ -6375,7 +6375,7 @@
               <a:t> từ</a:t>
             </a:r>
             <a:r>
-              <a:rPr lang="en-US" sz="2250" b="1" dirty="0" spc="2" kern="0">
+              <a:rPr lang="en-US" sz="2550" b="1" dirty="0" spc="-4" kern="0">
                 <a:solidFill>
                   <a:srgbClr val="F3EEE3"/>
                 </a:solidFill>
@@ -6385,7 +6385,7 @@
               </a:rPr>
               <a:t> đây</a:t>
             </a:r>
-            <a:endParaRPr lang="en-US" sz="2250" dirty="0"/>
+            <a:endParaRPr lang="en-US" sz="2550" dirty="0"/>
           </a:p>
         </p:txBody>
       </p:sp>
@@ -11147,12 +11147,12 @@
           <a:ln/>
         </p:spPr>
         <p:txBody>
-          <a:bodyPr wrap="square" lIns="0" tIns="5334" rIns="0" bIns="-5334" rtlCol="0" anchor="t"/>
+          <a:bodyPr wrap="square" lIns="0" tIns="5667" rIns="0" bIns="-5667" rtlCol="0" anchor="t"/>
           <a:lstStyle/>
           <a:p>
-            <a:pPr algn="l" marL="304800" indent="-217761">
+            <a:pPr algn="l" marL="323850" indent="-231371">
               <a:lnSpc>
-                <a:spcPts val="3360"/>
+                <a:spcPts val="3570"/>
               </a:lnSpc>
               <a:spcAft>
                 <a:spcPts val="900"/>
@@ -11162,7 +11162,7 @@
               <a:buChar char="•"/>
             </a:pPr>
             <a:r>
-              <a:rPr lang="en-US" sz="2400" dirty="0" spc="-8" kern="0">
+              <a:rPr lang="en-US" sz="2550" dirty="0" spc="-7" kern="0">
                 <a:solidFill>
                   <a:srgbClr val="14161C"/>
                 </a:solidFill>
@@ -11173,7 +11173,7 @@
               <a:t>static_configs:</a:t>
             </a:r>
             <a:r>
-              <a:rPr lang="en-US" sz="2400" dirty="0" spc="7" kern="0">
+              <a:rPr lang="en-US" sz="2550" dirty="0" spc="4" kern="0">
                 <a:solidFill>
                   <a:srgbClr val="14161C"/>
                 </a:solidFill>
@@ -11184,7 +11184,7 @@
               <a:t> người</a:t>
             </a:r>
             <a:r>
-              <a:rPr lang="en-US" sz="2400" dirty="0" spc="-12" kern="0">
+              <a:rPr lang="en-US" sz="2550" dirty="0" spc="-14" kern="0">
                 <a:solidFill>
                   <a:srgbClr val="14161C"/>
                 </a:solidFill>
@@ -11195,18 +11195,29 @@
               <a:t> vận</a:t>
             </a:r>
             <a:r>
-              <a:rPr lang="en-US" sz="2400" dirty="0" spc="1" kern="0">
-                <a:solidFill>
-                  <a:srgbClr val="14161C"/>
-                </a:solidFill>
-                <a:latin typeface="Be Vietnam Pro" pitchFamily="34" charset="0"/>
-                <a:ea typeface="Be Vietnam Pro" pitchFamily="34" charset="-122"/>
-                <a:cs typeface="Be Vietnam Pro" pitchFamily="34" charset="-120"/>
-              </a:rPr>
-              <a:t> hành cập</a:t>
-            </a:r>
-            <a:r>
-              <a:rPr lang="en-US" sz="2400" dirty="0" spc="-8" kern="0">
+              <a:rPr lang="en-US" sz="2550" dirty="0" spc="-1" kern="0">
+                <a:solidFill>
+                  <a:srgbClr val="14161C"/>
+                </a:solidFill>
+                <a:latin typeface="Be Vietnam Pro" pitchFamily="34" charset="0"/>
+                <a:ea typeface="Be Vietnam Pro" pitchFamily="34" charset="-122"/>
+                <a:cs typeface="Be Vietnam Pro" pitchFamily="34" charset="-120"/>
+              </a:rPr>
+              <a:t> hành</a:t>
+            </a:r>
+            <a:r>
+              <a:rPr lang="en-US" sz="2550" dirty="0" spc="1" kern="0">
+                <a:solidFill>
+                  <a:srgbClr val="14161C"/>
+                </a:solidFill>
+                <a:latin typeface="Be Vietnam Pro" pitchFamily="34" charset="0"/>
+                <a:ea typeface="Be Vietnam Pro" pitchFamily="34" charset="-122"/>
+                <a:cs typeface="Be Vietnam Pro" pitchFamily="34" charset="-120"/>
+              </a:rPr>
+              <a:t> cập</a:t>
+            </a:r>
+            <a:r>
+              <a:rPr lang="en-US" sz="2550" dirty="0" spc="-10" kern="0">
                 <a:solidFill>
                   <a:srgbClr val="14161C"/>
                 </a:solidFill>
@@ -11217,7 +11228,7 @@
               <a:t> nhật</a:t>
             </a:r>
             <a:r>
-              <a:rPr lang="en-US" sz="2400" dirty="0" spc="-16" kern="0">
+              <a:rPr lang="en-US" sz="2550" dirty="0" spc="-16" kern="0">
                 <a:solidFill>
                   <a:srgbClr val="14161C"/>
                 </a:solidFill>
@@ -11227,19 +11238,19 @@
               </a:rPr>
               <a:t> tay.</a:t>
             </a:r>
-            <a:endParaRPr lang="en-US" sz="2400" dirty="0"/>
+            <a:endParaRPr lang="en-US" sz="2550" dirty="0"/>
           </a:p>
           <a:p>
-            <a:pPr algn="l" marL="304800" indent="-217761">
+            <a:pPr algn="l" marL="323850" indent="-231371">
               <a:lnSpc>
-                <a:spcPts val="3360"/>
+                <a:spcPts val="3570"/>
               </a:lnSpc>
               <a:buSzPct val="100000"/>
               <a:buFont typeface="Arial"/>
               <a:buChar char="•"/>
             </a:pPr>
             <a:r>
-              <a:rPr lang="en-US" sz="2400" dirty="0" spc="-1" kern="0">
+              <a:rPr lang="en-US" sz="2550" dirty="0" spc="-1" kern="0">
                 <a:solidFill>
                   <a:srgbClr val="14161C"/>
                 </a:solidFill>
@@ -11250,7 +11261,7 @@
               <a:t>Service</a:t>
             </a:r>
             <a:r>
-              <a:rPr lang="en-US" sz="2400" dirty="0" spc="-13" kern="0">
+              <a:rPr lang="en-US" sz="2550" dirty="0" spc="-14" kern="0">
                 <a:solidFill>
                   <a:srgbClr val="14161C"/>
                 </a:solidFill>
@@ -11261,7 +11272,7 @@
               <a:t> discovery</a:t>
             </a:r>
             <a:r>
-              <a:rPr lang="en-US" sz="2400" dirty="0" spc="-1" kern="0">
+              <a:rPr lang="en-US" sz="2550" dirty="0" spc="-2" kern="0">
                 <a:solidFill>
                   <a:srgbClr val="14161C"/>
                 </a:solidFill>
@@ -11272,7 +11283,7 @@
               <a:t> theo</a:t>
             </a:r>
             <a:r>
-              <a:rPr lang="en-US" sz="2400" dirty="0" spc="0" kern="0">
+              <a:rPr lang="en-US" sz="2550" dirty="0" spc="1" kern="0">
                 <a:solidFill>
                   <a:srgbClr val="14161C"/>
                 </a:solidFill>
@@ -11283,7 +11294,7 @@
               <a:t> kịp,</a:t>
             </a:r>
             <a:r>
-              <a:rPr lang="en-US" sz="2400" dirty="0" spc="-2" kern="0">
+              <a:rPr lang="en-US" sz="2550" dirty="0" spc="-1" kern="0">
                 <a:solidFill>
                   <a:srgbClr val="14161C"/>
                 </a:solidFill>
@@ -11294,7 +11305,7 @@
               <a:t> khi</a:t>
             </a:r>
             <a:r>
-              <a:rPr lang="en-US" sz="2400" dirty="0" spc="18" kern="0">
+              <a:rPr lang="en-US" sz="2550" dirty="0" spc="18" kern="0">
                 <a:solidFill>
                   <a:srgbClr val="14161C"/>
                 </a:solidFill>
@@ -11305,17 +11316,28 @@
               <a:t> đã</a:t>
             </a:r>
             <a:r>
-              <a:rPr lang="en-US" sz="2400" dirty="0" spc="0" kern="0">
-                <a:solidFill>
-                  <a:srgbClr val="14161C"/>
-                </a:solidFill>
-                <a:latin typeface="Be Vietnam Pro" pitchFamily="34" charset="0"/>
-                <a:ea typeface="Be Vietnam Pro" pitchFamily="34" charset="-122"/>
-                <a:cs typeface="Be Vietnam Pro" pitchFamily="34" charset="-120"/>
-              </a:rPr>
-              <a:t> cấu hình.</a:t>
-            </a:r>
-            <a:endParaRPr lang="en-US" sz="2400" dirty="0"/>
+              <a:rPr lang="en-US" sz="2550" dirty="0" spc="2" kern="0">
+                <a:solidFill>
+                  <a:srgbClr val="14161C"/>
+                </a:solidFill>
+                <a:latin typeface="Be Vietnam Pro" pitchFamily="34" charset="0"/>
+                <a:ea typeface="Be Vietnam Pro" pitchFamily="34" charset="-122"/>
+                <a:cs typeface="Be Vietnam Pro" pitchFamily="34" charset="-120"/>
+              </a:rPr>
+              <a:t> cấu</a:t>
+            </a:r>
+            <a:r>
+              <a:rPr lang="en-US" sz="2550" dirty="0" spc="1" kern="0">
+                <a:solidFill>
+                  <a:srgbClr val="14161C"/>
+                </a:solidFill>
+                <a:latin typeface="Be Vietnam Pro" pitchFamily="34" charset="0"/>
+                <a:ea typeface="Be Vietnam Pro" pitchFamily="34" charset="-122"/>
+                <a:cs typeface="Be Vietnam Pro" pitchFamily="34" charset="-120"/>
+              </a:rPr>
+              <a:t> hình.</a:t>
+            </a:r>
+            <a:endParaRPr lang="en-US" sz="2550" dirty="0"/>
           </a:p>
         </p:txBody>
       </p:sp>
@@ -11442,12 +11464,12 @@
           <a:ln/>
         </p:spPr>
         <p:txBody>
-          <a:bodyPr wrap="square" lIns="0" tIns="5334" rIns="0" bIns="-5334" rtlCol="0" anchor="t"/>
+          <a:bodyPr wrap="square" lIns="0" tIns="5667" rIns="0" bIns="-5667" rtlCol="0" anchor="t"/>
           <a:lstStyle/>
           <a:p>
-            <a:pPr algn="l" marL="304800" indent="-217761">
+            <a:pPr algn="l" marL="323850" indent="-231371">
               <a:lnSpc>
-                <a:spcPts val="3360"/>
+                <a:spcPts val="3570"/>
               </a:lnSpc>
               <a:spcAft>
                 <a:spcPts val="900"/>
@@ -11457,7 +11479,7 @@
               <a:buChar char="•"/>
             </a:pPr>
             <a:r>
-              <a:rPr lang="en-US" sz="2400" dirty="0" spc="-1" kern="0">
+              <a:rPr lang="en-US" sz="2550" dirty="0" spc="-1" kern="0">
                 <a:solidFill>
                   <a:srgbClr val="14161C"/>
                 </a:solidFill>
@@ -11468,7 +11490,7 @@
               <a:t>Mỗi</a:t>
             </a:r>
             <a:r>
-              <a:rPr lang="en-US" sz="2400" dirty="0" spc="1" kern="0">
+              <a:rPr lang="en-US" sz="2550" dirty="0" spc="0" kern="0">
                 <a:solidFill>
                   <a:srgbClr val="14161C"/>
                 </a:solidFill>
@@ -11479,7 +11501,7 @@
               <a:t> lần</a:t>
             </a:r>
             <a:r>
-              <a:rPr lang="en-US" sz="2400" dirty="0" spc="-24" kern="0">
+              <a:rPr lang="en-US" sz="2550" dirty="0" spc="-25" kern="0">
                 <a:solidFill>
                   <a:srgbClr val="14161C"/>
                 </a:solidFill>
@@ -11490,7 +11512,7 @@
               <a:t> kéo,</a:t>
             </a:r>
             <a:r>
-              <a:rPr lang="en-US" sz="2400" dirty="0" spc="-11" kern="0">
+              <a:rPr lang="en-US" sz="2550" dirty="0" spc="-10" kern="0">
                 <a:solidFill>
                   <a:srgbClr val="14161C"/>
                 </a:solidFill>
@@ -11501,7 +11523,7 @@
               <a:t> Prometheus</a:t>
             </a:r>
             <a:r>
-              <a:rPr lang="en-US" sz="2400" dirty="0" spc="2" kern="0">
+              <a:rPr lang="en-US" sz="2550" dirty="0" spc="-1" kern="0">
                 <a:solidFill>
                   <a:srgbClr val="14161C"/>
                 </a:solidFill>
@@ -11512,7 +11534,7 @@
               <a:t> ghi</a:t>
             </a:r>
             <a:r>
-              <a:rPr lang="en-US" sz="2400" dirty="0" spc="-9" kern="0">
+              <a:rPr lang="en-US" sz="2550" dirty="0" spc="-10" kern="0">
                 <a:solidFill>
                   <a:srgbClr val="14161C"/>
                 </a:solidFill>
@@ -11523,7 +11545,7 @@
               <a:t> số</a:t>
             </a:r>
             <a:r>
-              <a:rPr lang="en-US" sz="2400" dirty="0" spc="19" kern="0">
+              <a:rPr lang="en-US" sz="2550" dirty="0" spc="17" kern="0">
                 <a:solidFill>
                   <a:srgbClr val="14161C"/>
                 </a:solidFill>
@@ -11534,7 +11556,7 @@
               <a:t> đo</a:t>
             </a:r>
             <a:r>
-              <a:rPr lang="en-US" sz="2400" dirty="0" spc="-1" kern="0">
+              <a:rPr lang="en-US" sz="2550" dirty="0" spc="2" kern="0">
                 <a:solidFill>
                   <a:srgbClr val="14161C"/>
                 </a:solidFill>
@@ -11544,19 +11566,19 @@
               </a:rPr>
               <a:t> up.</a:t>
             </a:r>
-            <a:endParaRPr lang="en-US" sz="2400" dirty="0"/>
+            <a:endParaRPr lang="en-US" sz="2550" dirty="0"/>
           </a:p>
           <a:p>
-            <a:pPr algn="l" marL="304800" indent="-217761">
+            <a:pPr algn="l" marL="323850" indent="-231371">
               <a:lnSpc>
-                <a:spcPts val="3360"/>
+                <a:spcPts val="3570"/>
               </a:lnSpc>
               <a:buSzPct val="100000"/>
               <a:buFont typeface="Arial"/>
               <a:buChar char="•"/>
             </a:pPr>
             <a:r>
-              <a:rPr lang="en-US" sz="2400" dirty="0" spc="0" kern="0">
+              <a:rPr lang="en-US" sz="2550" dirty="0" spc="0" kern="0">
                 <a:solidFill>
                   <a:srgbClr val="14161C"/>
                 </a:solidFill>
@@ -11567,7 +11589,7 @@
               <a:t>Cho</a:t>
             </a:r>
             <a:r>
-              <a:rPr lang="en-US" sz="2400" dirty="0" spc="-4" kern="0">
+              <a:rPr lang="en-US" sz="2550" dirty="0" spc="-4" kern="0">
                 <a:solidFill>
                   <a:srgbClr val="14161C"/>
                 </a:solidFill>
@@ -11578,7 +11600,7 @@
               <a:t> biết</a:t>
             </a:r>
             <a:r>
-              <a:rPr lang="en-US" sz="2400" dirty="0" spc="1" kern="0">
+              <a:rPr lang="en-US" sz="2550" dirty="0" spc="0" kern="0">
                 <a:solidFill>
                   <a:srgbClr val="14161C"/>
                 </a:solidFill>
@@ -11589,7 +11611,7 @@
               <a:t> lần</a:t>
             </a:r>
             <a:r>
-              <a:rPr lang="en-US" sz="2400" dirty="0" spc="-30" kern="0">
+              <a:rPr lang="en-US" sz="2550" dirty="0" spc="-31" kern="0">
                 <a:solidFill>
                   <a:srgbClr val="14161C"/>
                 </a:solidFill>
@@ -11600,28 +11622,28 @@
               <a:t> kéo</a:t>
             </a:r>
             <a:r>
-              <a:rPr lang="en-US" sz="2400" dirty="0" spc="0" kern="0">
-                <a:solidFill>
-                  <a:srgbClr val="14161C"/>
-                </a:solidFill>
-                <a:latin typeface="Be Vietnam Pro" pitchFamily="34" charset="0"/>
-                <a:ea typeface="Be Vietnam Pro" pitchFamily="34" charset="-122"/>
-                <a:cs typeface="Be Vietnam Pro" pitchFamily="34" charset="-120"/>
-              </a:rPr>
-              <a:t> có</a:t>
-            </a:r>
-            <a:r>
-              <a:rPr lang="en-US" sz="2400" dirty="0" spc="1" kern="0">
-                <a:solidFill>
-                  <a:srgbClr val="14161C"/>
-                </a:solidFill>
-                <a:latin typeface="Be Vietnam Pro" pitchFamily="34" charset="0"/>
-                <a:ea typeface="Be Vietnam Pro" pitchFamily="34" charset="-122"/>
-                <a:cs typeface="Be Vietnam Pro" pitchFamily="34" charset="-120"/>
-              </a:rPr>
-              <a:t> thành công không.</a:t>
-            </a:r>
-            <a:endParaRPr lang="en-US" sz="2400" dirty="0"/>
+              <a:rPr lang="en-US" sz="2550" dirty="0" spc="0" kern="0">
+                <a:solidFill>
+                  <a:srgbClr val="14161C"/>
+                </a:solidFill>
+                <a:latin typeface="Be Vietnam Pro" pitchFamily="34" charset="0"/>
+                <a:ea typeface="Be Vietnam Pro" pitchFamily="34" charset="-122"/>
+                <a:cs typeface="Be Vietnam Pro" pitchFamily="34" charset="-120"/>
+              </a:rPr>
+              <a:t> có thành</a:t>
+            </a:r>
+            <a:r>
+              <a:rPr lang="en-US" sz="2550" dirty="0" spc="1" kern="0">
+                <a:solidFill>
+                  <a:srgbClr val="14161C"/>
+                </a:solidFill>
+                <a:latin typeface="Be Vietnam Pro" pitchFamily="34" charset="0"/>
+                <a:ea typeface="Be Vietnam Pro" pitchFamily="34" charset="-122"/>
+                <a:cs typeface="Be Vietnam Pro" pitchFamily="34" charset="-120"/>
+              </a:rPr>
+              <a:t> công không.</a:t>
+            </a:r>
+            <a:endParaRPr lang="en-US" sz="2550" dirty="0"/>
           </a:p>
         </p:txBody>
       </p:sp>
@@ -11726,12 +11748,12 @@
           <a:ln/>
         </p:spPr>
         <p:txBody>
-          <a:bodyPr wrap="square" lIns="0" tIns="5334" rIns="0" bIns="-5334" rtlCol="0" anchor="t"/>
+          <a:bodyPr wrap="square" lIns="0" tIns="5667" rIns="0" bIns="-5667" rtlCol="0" anchor="t"/>
           <a:lstStyle/>
           <a:p>
-            <a:pPr algn="l" marL="304800" indent="-217761">
+            <a:pPr algn="l" marL="323850" indent="-231371">
               <a:lnSpc>
-                <a:spcPts val="3360"/>
+                <a:spcPts val="3570"/>
               </a:lnSpc>
               <a:spcAft>
                 <a:spcPts val="900"/>
@@ -11741,7 +11763,7 @@
               <a:buChar char="•"/>
             </a:pPr>
             <a:r>
-              <a:rPr lang="en-US" sz="2400" dirty="0" spc="0" kern="0">
+              <a:rPr lang="en-US" sz="2550" dirty="0" spc="1" kern="0">
                 <a:solidFill>
                   <a:srgbClr val="14161C"/>
                 </a:solidFill>
@@ -11752,7 +11774,7 @@
               <a:t>Nhận</a:t>
             </a:r>
             <a:r>
-              <a:rPr lang="en-US" sz="2400" dirty="0" spc="-9" kern="0">
+              <a:rPr lang="en-US" sz="2550" dirty="0" spc="-10" kern="0">
                 <a:solidFill>
                   <a:srgbClr val="14161C"/>
                 </a:solidFill>
@@ -11763,7 +11785,7 @@
               <a:t> số</a:t>
             </a:r>
             <a:r>
-              <a:rPr lang="en-US" sz="2400" dirty="0" spc="18" kern="0">
+              <a:rPr lang="en-US" sz="2550" dirty="0" spc="17" kern="0">
                 <a:solidFill>
                   <a:srgbClr val="14161C"/>
                 </a:solidFill>
@@ -11774,7 +11796,7 @@
               <a:t> đo</a:t>
             </a:r>
             <a:r>
-              <a:rPr lang="en-US" sz="2400" dirty="0" spc="4" kern="0">
+              <a:rPr lang="en-US" sz="2550" dirty="0" spc="-1" kern="0">
                 <a:solidFill>
                   <a:srgbClr val="14161C"/>
                 </a:solidFill>
@@ -11785,7 +11807,7 @@
               <a:t> từ</a:t>
             </a:r>
             <a:r>
-              <a:rPr lang="en-US" sz="2400" dirty="0" spc="-11" kern="0">
+              <a:rPr lang="en-US" sz="2550" dirty="0" spc="-11" kern="0">
                 <a:solidFill>
                   <a:srgbClr val="14161C"/>
                 </a:solidFill>
@@ -11796,7 +11818,7 @@
               <a:t> tác</a:t>
             </a:r>
             <a:r>
-              <a:rPr lang="en-US" sz="2400" dirty="0" spc="1" kern="0">
+              <a:rPr lang="en-US" sz="2550" dirty="0" spc="-5" kern="0">
                 <a:solidFill>
                   <a:srgbClr val="14161C"/>
                 </a:solidFill>
@@ -11807,7 +11829,7 @@
               <a:t> vụ</a:t>
             </a:r>
             <a:r>
-              <a:rPr lang="en-US" sz="2400" dirty="0" spc="-6" kern="0">
+              <a:rPr lang="en-US" sz="2550" dirty="0" spc="-7" kern="0">
                 <a:solidFill>
                   <a:srgbClr val="14161C"/>
                 </a:solidFill>
@@ -11817,19 +11839,19 @@
               </a:rPr>
               <a:t> ngắn.</a:t>
             </a:r>
-            <a:endParaRPr lang="en-US" sz="2400" dirty="0"/>
+            <a:endParaRPr lang="en-US" sz="2550" dirty="0"/>
           </a:p>
           <a:p>
-            <a:pPr algn="l" marL="304800" indent="-217761">
+            <a:pPr algn="l" marL="323850" indent="-231371">
               <a:lnSpc>
-                <a:spcPts val="3360"/>
+                <a:spcPts val="3570"/>
               </a:lnSpc>
               <a:buSzPct val="100000"/>
               <a:buFont typeface="Arial"/>
               <a:buChar char="•"/>
             </a:pPr>
             <a:r>
-              <a:rPr lang="en-US" sz="2400" dirty="0" spc="2" kern="0">
+              <a:rPr lang="en-US" sz="2550" dirty="0" spc="-1" kern="0">
                 <a:solidFill>
                   <a:srgbClr val="14161C"/>
                 </a:solidFill>
@@ -11840,29 +11862,18 @@
               <a:t>Không</a:t>
             </a:r>
             <a:r>
-              <a:rPr lang="en-US" sz="2400" dirty="0" spc="1" kern="0">
-                <a:solidFill>
-                  <a:srgbClr val="14161C"/>
-                </a:solidFill>
-                <a:latin typeface="Be Vietnam Pro" pitchFamily="34" charset="0"/>
-                <a:ea typeface="Be Vietnam Pro" pitchFamily="34" charset="-122"/>
-                <a:cs typeface="Be Vietnam Pro" pitchFamily="34" charset="-120"/>
-              </a:rPr>
-              <a:t> phải</a:t>
-            </a:r>
-            <a:r>
-              <a:rPr lang="en-US" sz="2400" dirty="0" spc="0" kern="0">
-                <a:solidFill>
-                  <a:srgbClr val="14161C"/>
-                </a:solidFill>
-                <a:latin typeface="Be Vietnam Pro" pitchFamily="34" charset="0"/>
-                <a:ea typeface="Be Vietnam Pro" pitchFamily="34" charset="-122"/>
-                <a:cs typeface="Be Vietnam Pro" pitchFamily="34" charset="-120"/>
-              </a:rPr>
-              <a:t> cách</a:t>
-            </a:r>
-            <a:r>
-              <a:rPr lang="en-US" sz="2400" dirty="0" spc="5" kern="0">
+              <a:rPr lang="en-US" sz="2550" dirty="0" spc="0" kern="0">
+                <a:solidFill>
+                  <a:srgbClr val="14161C"/>
+                </a:solidFill>
+                <a:latin typeface="Be Vietnam Pro" pitchFamily="34" charset="0"/>
+                <a:ea typeface="Be Vietnam Pro" pitchFamily="34" charset="-122"/>
+                <a:cs typeface="Be Vietnam Pro" pitchFamily="34" charset="-120"/>
+              </a:rPr>
+              <a:t> phải cách</a:t>
+            </a:r>
+            <a:r>
+              <a:rPr lang="en-US" sz="2550" dirty="0" spc="4" kern="0">
                 <a:solidFill>
                   <a:srgbClr val="14161C"/>
                 </a:solidFill>
@@ -11873,40 +11884,40 @@
               <a:t> đẩy</a:t>
             </a:r>
             <a:r>
-              <a:rPr lang="en-US" sz="2400" dirty="0" spc="0" kern="0">
-                <a:solidFill>
-                  <a:srgbClr val="14161C"/>
-                </a:solidFill>
-                <a:latin typeface="Be Vietnam Pro" pitchFamily="34" charset="0"/>
-                <a:ea typeface="Be Vietnam Pro" pitchFamily="34" charset="-122"/>
-                <a:cs typeface="Be Vietnam Pro" pitchFamily="34" charset="-120"/>
-              </a:rPr>
-              <a:t> chung cho</a:t>
-            </a:r>
-            <a:r>
-              <a:rPr lang="en-US" sz="2400" dirty="0" spc="1" kern="0">
-                <a:solidFill>
-                  <a:srgbClr val="14161C"/>
-                </a:solidFill>
-                <a:latin typeface="Be Vietnam Pro" pitchFamily="34" charset="0"/>
-                <a:ea typeface="Be Vietnam Pro" pitchFamily="34" charset="-122"/>
-                <a:cs typeface="Be Vietnam Pro" pitchFamily="34" charset="-120"/>
-              </a:rPr>
-              <a:t> mọi</a:t>
-            </a:r>
-            <a:r>
-              <a:rPr lang="en-US" sz="2400" dirty="0" spc="0" kern="0">
-                <a:solidFill>
-                  <a:srgbClr val="14161C"/>
-                </a:solidFill>
-                <a:latin typeface="Be Vietnam Pro" pitchFamily="34" charset="0"/>
-                <a:ea typeface="Be Vietnam Pro" pitchFamily="34" charset="-122"/>
-                <a:cs typeface="Be Vietnam Pro" pitchFamily="34" charset="-120"/>
-              </a:rPr>
-              <a:t> dịch</a:t>
-            </a:r>
-            <a:r>
-              <a:rPr lang="en-US" sz="2400" dirty="0" spc="1" kern="0">
+              <a:rPr lang="en-US" sz="2550" dirty="0" spc="1" kern="0">
+                <a:solidFill>
+                  <a:srgbClr val="14161C"/>
+                </a:solidFill>
+                <a:latin typeface="Be Vietnam Pro" pitchFamily="34" charset="0"/>
+                <a:ea typeface="Be Vietnam Pro" pitchFamily="34" charset="-122"/>
+                <a:cs typeface="Be Vietnam Pro" pitchFamily="34" charset="-120"/>
+              </a:rPr>
+              <a:t> chung</a:t>
+            </a:r>
+            <a:r>
+              <a:rPr lang="en-US" sz="2550" dirty="0" spc="-1" kern="0">
+                <a:solidFill>
+                  <a:srgbClr val="14161C"/>
+                </a:solidFill>
+                <a:latin typeface="Be Vietnam Pro" pitchFamily="34" charset="0"/>
+                <a:ea typeface="Be Vietnam Pro" pitchFamily="34" charset="-122"/>
+                <a:cs typeface="Be Vietnam Pro" pitchFamily="34" charset="-120"/>
+              </a:rPr>
+              <a:t> cho</a:t>
+            </a:r>
+            <a:r>
+              <a:rPr lang="en-US" sz="2550" dirty="0" spc="0" kern="0">
+                <a:solidFill>
+                  <a:srgbClr val="14161C"/>
+                </a:solidFill>
+                <a:latin typeface="Be Vietnam Pro" pitchFamily="34" charset="0"/>
+                <a:ea typeface="Be Vietnam Pro" pitchFamily="34" charset="-122"/>
+                <a:cs typeface="Be Vietnam Pro" pitchFamily="34" charset="-120"/>
+              </a:rPr>
+              <a:t> mọi dịch</a:t>
+            </a:r>
+            <a:r>
+              <a:rPr lang="en-US" sz="2550" dirty="0" spc="-2" kern="0">
                 <a:solidFill>
                   <a:srgbClr val="14161C"/>
                 </a:solidFill>
@@ -11916,7 +11927,7 @@
               </a:rPr>
               <a:t> vụ.</a:t>
             </a:r>
-            <a:endParaRPr lang="en-US" sz="2400" dirty="0"/>
+            <a:endParaRPr lang="en-US" sz="2550" dirty="0"/>
           </a:p>
         </p:txBody>
       </p:sp>
@@ -12054,12 +12065,12 @@
           <a:ln/>
         </p:spPr>
         <p:txBody>
-          <a:bodyPr wrap="square" lIns="0" tIns="5334" rIns="0" bIns="-5334" rtlCol="0" anchor="t"/>
+          <a:bodyPr wrap="square" lIns="0" tIns="5667" rIns="0" bIns="-5667" rtlCol="0" anchor="t"/>
           <a:lstStyle/>
           <a:p>
-            <a:pPr algn="l" marL="304800" indent="-217761">
+            <a:pPr algn="l" marL="323850" indent="-231371">
               <a:lnSpc>
-                <a:spcPts val="3360"/>
+                <a:spcPts val="3570"/>
               </a:lnSpc>
               <a:spcAft>
                 <a:spcPts val="900"/>
@@ -12069,7 +12080,7 @@
               <a:buChar char="•"/>
             </a:pPr>
             <a:r>
-              <a:rPr lang="en-US" sz="2400" dirty="0" spc="-26" kern="0">
+              <a:rPr lang="en-US" sz="2550" dirty="0" spc="-29" kern="0">
                 <a:solidFill>
                   <a:srgbClr val="14161C"/>
                 </a:solidFill>
@@ -12080,7 +12091,7 @@
               <a:t>Agent</a:t>
             </a:r>
             <a:r>
-              <a:rPr lang="en-US" sz="2400" dirty="0" spc="-31" kern="0">
+              <a:rPr lang="en-US" sz="2550" dirty="0" spc="-31" kern="0">
                 <a:solidFill>
                   <a:srgbClr val="14161C"/>
                 </a:solidFill>
@@ -12091,18 +12102,29 @@
               <a:t> kéo</a:t>
             </a:r>
             <a:r>
-              <a:rPr lang="en-US" sz="2400" dirty="0" spc="0" kern="0">
-                <a:solidFill>
-                  <a:srgbClr val="14161C"/>
-                </a:solidFill>
-                <a:latin typeface="Be Vietnam Pro" pitchFamily="34" charset="0"/>
-                <a:ea typeface="Be Vietnam Pro" pitchFamily="34" charset="-122"/>
-                <a:cs typeface="Be Vietnam Pro" pitchFamily="34" charset="-120"/>
-              </a:rPr>
-              <a:t> cục bộ,</a:t>
-            </a:r>
-            <a:r>
-              <a:rPr lang="en-US" sz="2400" dirty="0" spc="-13" kern="0">
+              <a:rPr lang="en-US" sz="2550" dirty="0" spc="-1" kern="0">
+                <a:solidFill>
+                  <a:srgbClr val="14161C"/>
+                </a:solidFill>
+                <a:latin typeface="Be Vietnam Pro" pitchFamily="34" charset="0"/>
+                <a:ea typeface="Be Vietnam Pro" pitchFamily="34" charset="-122"/>
+                <a:cs typeface="Be Vietnam Pro" pitchFamily="34" charset="-120"/>
+              </a:rPr>
+              <a:t> cục</a:t>
+            </a:r>
+            <a:r>
+              <a:rPr lang="en-US" sz="2550" dirty="0" spc="-4" kern="0">
+                <a:solidFill>
+                  <a:srgbClr val="14161C"/>
+                </a:solidFill>
+                <a:latin typeface="Be Vietnam Pro" pitchFamily="34" charset="0"/>
+                <a:ea typeface="Be Vietnam Pro" pitchFamily="34" charset="-122"/>
+                <a:cs typeface="Be Vietnam Pro" pitchFamily="34" charset="-120"/>
+              </a:rPr>
+              <a:t> bộ,</a:t>
+            </a:r>
+            <a:r>
+              <a:rPr lang="en-US" sz="2550" dirty="0" spc="-12" kern="0">
                 <a:solidFill>
                   <a:srgbClr val="14161C"/>
                 </a:solidFill>
@@ -12113,29 +12135,18 @@
               <a:t> chuyển</a:t>
             </a:r>
             <a:r>
-              <a:rPr lang="en-US" sz="2400" dirty="0" spc="0" kern="0">
-                <a:solidFill>
-                  <a:srgbClr val="14161C"/>
-                </a:solidFill>
-                <a:latin typeface="Be Vietnam Pro" pitchFamily="34" charset="0"/>
-                <a:ea typeface="Be Vietnam Pro" pitchFamily="34" charset="-122"/>
-                <a:cs typeface="Be Vietnam Pro" pitchFamily="34" charset="-120"/>
-              </a:rPr>
-              <a:t> tiếp</a:t>
-            </a:r>
-            <a:r>
-              <a:rPr lang="en-US" sz="2400" dirty="0" spc="2" kern="0">
-                <a:solidFill>
-                  <a:srgbClr val="14161C"/>
-                </a:solidFill>
-                <a:latin typeface="Be Vietnam Pro" pitchFamily="34" charset="0"/>
-                <a:ea typeface="Be Vietnam Pro" pitchFamily="34" charset="-122"/>
-                <a:cs typeface="Be Vietnam Pro" pitchFamily="34" charset="-120"/>
-              </a:rPr>
-              <a:t> mẫu;</a:t>
-            </a:r>
-            <a:r>
-              <a:rPr lang="en-US" sz="2400" dirty="0" spc="-12" kern="0">
+              <a:rPr lang="en-US" sz="2550" dirty="0" spc="1" kern="0">
+                <a:solidFill>
+                  <a:srgbClr val="14161C"/>
+                </a:solidFill>
+                <a:latin typeface="Be Vietnam Pro" pitchFamily="34" charset="0"/>
+                <a:ea typeface="Be Vietnam Pro" pitchFamily="34" charset="-122"/>
+                <a:cs typeface="Be Vietnam Pro" pitchFamily="34" charset="-120"/>
+              </a:rPr>
+              <a:t> tiếp mẫu;</a:t>
+            </a:r>
+            <a:r>
+              <a:rPr lang="en-US" sz="2550" dirty="0" spc="-14" kern="0">
                 <a:solidFill>
                   <a:srgbClr val="14161C"/>
                 </a:solidFill>
@@ -12146,40 +12157,62 @@
               <a:t> vẫn</a:t>
             </a:r>
             <a:r>
-              <a:rPr lang="en-US" sz="2400" dirty="0" spc="0" kern="0">
-                <a:solidFill>
-                  <a:srgbClr val="14161C"/>
-                </a:solidFill>
-                <a:latin typeface="Be Vietnam Pro" pitchFamily="34" charset="0"/>
-                <a:ea typeface="Be Vietnam Pro" pitchFamily="34" charset="-122"/>
-                <a:cs typeface="Be Vietnam Pro" pitchFamily="34" charset="-120"/>
-              </a:rPr>
-              <a:t> có up.</a:t>
-            </a:r>
-            <a:endParaRPr lang="en-US" sz="2400" dirty="0"/>
+              <a:rPr lang="en-US" sz="2550" dirty="0" spc="0" kern="0">
+                <a:solidFill>
+                  <a:srgbClr val="14161C"/>
+                </a:solidFill>
+                <a:latin typeface="Be Vietnam Pro" pitchFamily="34" charset="0"/>
+                <a:ea typeface="Be Vietnam Pro" pitchFamily="34" charset="-122"/>
+                <a:cs typeface="Be Vietnam Pro" pitchFamily="34" charset="-120"/>
+              </a:rPr>
+              <a:t> có</a:t>
+            </a:r>
+            <a:r>
+              <a:rPr lang="en-US" sz="2550" dirty="0" spc="3" kern="0">
+                <a:solidFill>
+                  <a:srgbClr val="14161C"/>
+                </a:solidFill>
+                <a:latin typeface="Be Vietnam Pro" pitchFamily="34" charset="0"/>
+                <a:ea typeface="Be Vietnam Pro" pitchFamily="34" charset="-122"/>
+                <a:cs typeface="Be Vietnam Pro" pitchFamily="34" charset="-120"/>
+              </a:rPr>
+              <a:t> up.</a:t>
+            </a:r>
+            <a:endParaRPr lang="en-US" sz="2550" dirty="0"/>
           </a:p>
           <a:p>
-            <a:pPr algn="l" marL="304800" indent="-217761">
+            <a:pPr algn="l" marL="323850" indent="-231371">
               <a:lnSpc>
-                <a:spcPts val="3360"/>
+                <a:spcPts val="3570"/>
               </a:lnSpc>
               <a:buSzPct val="100000"/>
               <a:buFont typeface="Arial"/>
               <a:buChar char="•"/>
             </a:pPr>
             <a:r>
-              <a:rPr lang="en-US" sz="2400" dirty="0" spc="2" kern="0">
-                <a:solidFill>
-                  <a:srgbClr val="14161C"/>
-                </a:solidFill>
-                <a:latin typeface="Be Vietnam Pro" pitchFamily="34" charset="0"/>
-                <a:ea typeface="Be Vietnam Pro" pitchFamily="34" charset="-122"/>
-                <a:cs typeface="Be Vietnam Pro" pitchFamily="34" charset="-120"/>
-              </a:rPr>
-              <a:t>Không dành</a:t>
-            </a:r>
-            <a:r>
-              <a:rPr lang="en-US" sz="2400" dirty="0" spc="0" kern="0">
+              <a:rPr lang="en-US" sz="2550" dirty="0" spc="-1" kern="0">
+                <a:solidFill>
+                  <a:srgbClr val="14161C"/>
+                </a:solidFill>
+                <a:latin typeface="Be Vietnam Pro" pitchFamily="34" charset="0"/>
+                <a:ea typeface="Be Vietnam Pro" pitchFamily="34" charset="-122"/>
+                <a:cs typeface="Be Vietnam Pro" pitchFamily="34" charset="-120"/>
+              </a:rPr>
+              <a:t>Không</a:t>
+            </a:r>
+            <a:r>
+              <a:rPr lang="en-US" sz="2550" dirty="0" spc="0" kern="0">
+                <a:solidFill>
+                  <a:srgbClr val="14161C"/>
+                </a:solidFill>
+                <a:latin typeface="Be Vietnam Pro" pitchFamily="34" charset="0"/>
+                <a:ea typeface="Be Vietnam Pro" pitchFamily="34" charset="-122"/>
+                <a:cs typeface="Be Vietnam Pro" pitchFamily="34" charset="-120"/>
+              </a:rPr>
+              <a:t> dành</a:t>
+            </a:r>
+            <a:r>
+              <a:rPr lang="en-US" sz="2550" dirty="0" spc="-1" kern="0">
                 <a:solidFill>
                   <a:srgbClr val="14161C"/>
                 </a:solidFill>
@@ -12190,7 +12223,7 @@
               <a:t> cho</a:t>
             </a:r>
             <a:r>
-              <a:rPr lang="en-US" sz="2400" dirty="0" spc="28" kern="0">
+              <a:rPr lang="en-US" sz="2550" dirty="0" spc="24" kern="0">
                 <a:solidFill>
                   <a:srgbClr val="14161C"/>
                 </a:solidFill>
@@ -12201,7 +12234,7 @@
               <a:t> ứng</a:t>
             </a:r>
             <a:r>
-              <a:rPr lang="en-US" sz="2400" dirty="0" spc="3" kern="0">
+              <a:rPr lang="en-US" sz="2550" dirty="0" spc="-1" kern="0">
                 <a:solidFill>
                   <a:srgbClr val="14161C"/>
                 </a:solidFill>
@@ -12212,7 +12245,7 @@
               <a:t> dụng tự</a:t>
             </a:r>
             <a:r>
-              <a:rPr lang="en-US" sz="2400" dirty="0" spc="5" kern="0">
+              <a:rPr lang="en-US" sz="2550" dirty="0" spc="4" kern="0">
                 <a:solidFill>
                   <a:srgbClr val="14161C"/>
                 </a:solidFill>
@@ -12223,7 +12256,7 @@
               <a:t> đẩy</a:t>
             </a:r>
             <a:r>
-              <a:rPr lang="en-US" sz="2400" dirty="0" spc="-8" kern="0">
+              <a:rPr lang="en-US" sz="2550" dirty="0" spc="-11" kern="0">
                 <a:solidFill>
                   <a:srgbClr val="14161C"/>
                 </a:solidFill>
@@ -12234,7 +12267,7 @@
               <a:t> số</a:t>
             </a:r>
             <a:r>
-              <a:rPr lang="en-US" sz="2400" dirty="0" spc="13" kern="0">
+              <a:rPr lang="en-US" sz="2550" dirty="0" spc="14" kern="0">
                 <a:solidFill>
                   <a:srgbClr val="14161C"/>
                 </a:solidFill>
@@ -12244,7 +12277,7 @@
               </a:rPr>
               <a:t> đo.</a:t>
             </a:r>
-            <a:endParaRPr lang="en-US" sz="2400" dirty="0"/>
+            <a:endParaRPr lang="en-US" sz="2550" dirty="0"/>
           </a:p>
         </p:txBody>
       </p:sp>

</xml_diff>

<commit_message>
Slides: sd-13 bullets within the ten-word budget
Co-Authored-By: Claude Opus 5.5 <noreply@anthropic.com>
Claude-Session: https://claude.ai/code/session_01TQmrJYLm4GPgtXpQaEk7ey
</commit_message>
<xml_diff>
--- a/system-design-101/vi/lessons/sd-13-004/slides/sd-13-004.pptx
+++ b/system-design-101/vi/lessons/sd-13-004/slides/sd-13-004.pptx
@@ -2898,7 +2898,7 @@
                 <a:ea typeface="Be Vietnam Pro" pitchFamily="34" charset="-122"/>
                 <a:cs typeface="Be Vietnam Pro" pitchFamily="34" charset="-120"/>
               </a:rPr>
-              <a:t> nào hợp</a:t>
+              <a:t> hợp</a:t>
             </a:r>
             <a:r>
               <a:rPr lang="en-US" sz="2700" dirty="0" spc="-1" kern="0">
@@ -2909,7 +2909,18 @@
                 <a:ea typeface="Be Vietnam Pro" pitchFamily="34" charset="-122"/>
                 <a:cs typeface="Be Vietnam Pro" pitchFamily="34" charset="-120"/>
               </a:rPr>
-              <a:t> tùy</a:t>
+              <a:t> tùy dịch vụ</a:t>
+            </a:r>
+            <a:r>
+              <a:rPr lang="en-US" sz="2700" dirty="0" spc="-8" kern="0">
+                <a:solidFill>
+                  <a:srgbClr val="6B6A66"/>
+                </a:solidFill>
+                <a:latin typeface="Be Vietnam Pro" pitchFamily="34" charset="0"/>
+                <a:ea typeface="Be Vietnam Pro" pitchFamily="34" charset="-122"/>
+                <a:cs typeface="Be Vietnam Pro" pitchFamily="34" charset="-120"/>
+              </a:rPr>
+              <a:t> sống</a:t>
             </a:r>
             <a:r>
               <a:rPr lang="en-US" sz="2700" dirty="0" spc="-2" kern="0">
@@ -2920,10 +2931,10 @@
                 <a:ea typeface="Be Vietnam Pro" pitchFamily="34" charset="-122"/>
                 <a:cs typeface="Be Vietnam Pro" pitchFamily="34" charset="-120"/>
               </a:rPr>
-              <a:t> dịch</a:t>
-            </a:r>
-            <a:r>
-              <a:rPr lang="en-US" sz="2700" dirty="0" spc="0" kern="0">
+              <a:t> thế</a:t>
+            </a:r>
+            <a:r>
+              <a:rPr lang="en-US" sz="2700" dirty="0" spc="-1" kern="0">
                 <a:solidFill>
                   <a:srgbClr val="6B6A66"/>
                 </a:solidFill>
@@ -2931,10 +2942,10 @@
                 <a:ea typeface="Be Vietnam Pro" pitchFamily="34" charset="-122"/>
                 <a:cs typeface="Be Vietnam Pro" pitchFamily="34" charset="-120"/>
               </a:rPr>
-              <a:t> vụ</a:t>
-            </a:r>
-            <a:r>
-              <a:rPr lang="en-US" sz="2700" dirty="0" spc="-8" kern="0">
+              <a:t> nào,</a:t>
+            </a:r>
+            <a:r>
+              <a:rPr lang="en-US" sz="2700" dirty="0" spc="-2" kern="0">
                 <a:solidFill>
                   <a:srgbClr val="6B6A66"/>
                 </a:solidFill>
@@ -2942,40 +2953,7 @@
                 <a:ea typeface="Be Vietnam Pro" pitchFamily="34" charset="-122"/>
                 <a:cs typeface="Be Vietnam Pro" pitchFamily="34" charset="-120"/>
               </a:rPr>
-              <a:t> sống</a:t>
-            </a:r>
-            <a:r>
-              <a:rPr lang="en-US" sz="2700" dirty="0" spc="-2" kern="0">
-                <a:solidFill>
-                  <a:srgbClr val="6B6A66"/>
-                </a:solidFill>
-                <a:latin typeface="Be Vietnam Pro" pitchFamily="34" charset="0"/>
-                <a:ea typeface="Be Vietnam Pro" pitchFamily="34" charset="-122"/>
-                <a:cs typeface="Be Vietnam Pro" pitchFamily="34" charset="-120"/>
-              </a:rPr>
-              <a:t> thế</a:t>
-            </a:r>
-            <a:r>
-              <a:rPr lang="en-US" sz="2700" dirty="0" spc="-1" kern="0">
-                <a:solidFill>
-                  <a:srgbClr val="6B6A66"/>
-                </a:solidFill>
-                <a:latin typeface="Be Vietnam Pro" pitchFamily="34" charset="0"/>
-                <a:ea typeface="Be Vietnam Pro" pitchFamily="34" charset="-122"/>
-                <a:cs typeface="Be Vietnam Pro" pitchFamily="34" charset="-120"/>
-              </a:rPr>
-              <a:t> nào,</a:t>
-            </a:r>
-            <a:r>
-              <a:rPr lang="en-US" sz="2700" dirty="0" spc="-2" kern="0">
-                <a:solidFill>
-                  <a:srgbClr val="6B6A66"/>
-                </a:solidFill>
-                <a:latin typeface="Be Vietnam Pro" pitchFamily="34" charset="0"/>
-                <a:ea typeface="Be Vietnam Pro" pitchFamily="34" charset="-122"/>
-                <a:cs typeface="Be Vietnam Pro" pitchFamily="34" charset="-120"/>
-              </a:rPr>
-              <a:t> nằm ở</a:t>
+              <a:t> ở</a:t>
             </a:r>
             <a:r>
               <a:rPr lang="en-US" sz="2700" dirty="0" spc="10" kern="0">
@@ -8774,29 +8752,7 @@
               <a:t> sinh</a:t>
             </a:r>
             <a:r>
-              <a:rPr lang="en-US" sz="2550" dirty="0" spc="-10" kern="0">
-                <a:solidFill>
-                  <a:srgbClr val="14161C"/>
-                </a:solidFill>
-                <a:latin typeface="Be Vietnam Pro" pitchFamily="34" charset="0"/>
-                <a:ea typeface="Be Vietnam Pro" pitchFamily="34" charset="-122"/>
-                <a:cs typeface="Be Vietnam Pro" pitchFamily="34" charset="-120"/>
-              </a:rPr>
-              <a:t> số</a:t>
-            </a:r>
-            <a:r>
-              <a:rPr lang="en-US" sz="2550" dirty="0" spc="16" kern="0">
-                <a:solidFill>
-                  <a:srgbClr val="14161C"/>
-                </a:solidFill>
-                <a:latin typeface="Be Vietnam Pro" pitchFamily="34" charset="0"/>
-                <a:ea typeface="Be Vietnam Pro" pitchFamily="34" charset="-122"/>
-                <a:cs typeface="Be Vietnam Pro" pitchFamily="34" charset="-120"/>
-              </a:rPr>
-              <a:t> đo</a:t>
-            </a:r>
-            <a:r>
-              <a:rPr lang="en-US" sz="2550" dirty="0" spc="3" kern="0">
+              <a:rPr lang="en-US" sz="2550" dirty="0" spc="2" kern="0">
                 <a:solidFill>
                   <a:srgbClr val="14161C"/>
                 </a:solidFill>
@@ -8818,6 +8774,17 @@
               <a:t> mất</a:t>
             </a:r>
             <a:r>
+              <a:rPr lang="en-US" sz="2550" dirty="0" spc="2" kern="0">
+                <a:solidFill>
+                  <a:srgbClr val="14161C"/>
+                </a:solidFill>
+                <a:latin typeface="Be Vietnam Pro" pitchFamily="34" charset="0"/>
+                <a:ea typeface="Be Vietnam Pro" pitchFamily="34" charset="-122"/>
+                <a:cs typeface="Be Vietnam Pro" pitchFamily="34" charset="-120"/>
+              </a:rPr>
+              <a:t> tín</a:t>
+            </a:r>
+            <a:r>
               <a:rPr lang="en-US" sz="2550" dirty="0" spc="1" kern="0">
                 <a:solidFill>
                   <a:srgbClr val="14161C"/>
@@ -8826,10 +8793,10 @@
                 <a:ea typeface="Be Vietnam Pro" pitchFamily="34" charset="-122"/>
                 <a:cs typeface="Be Vietnam Pro" pitchFamily="34" charset="-120"/>
               </a:rPr>
-              <a:t> tín hiệu</a:t>
-            </a:r>
-            <a:r>
-              <a:rPr lang="en-US" sz="2550" dirty="0" spc="0" kern="0">
+              <a:t> hiệu</a:t>
+            </a:r>
+            <a:r>
+              <a:rPr lang="en-US" sz="2550" dirty="0" spc="-1" kern="0">
                 <a:solidFill>
                   <a:srgbClr val="14161C"/>
                 </a:solidFill>
@@ -8840,7 +8807,7 @@
               <a:t> còn</a:t>
             </a:r>
             <a:r>
-              <a:rPr lang="en-US" sz="2550" dirty="0" spc="-5" kern="0">
+              <a:rPr lang="en-US" sz="2550" dirty="0" spc="-4" kern="0">
                 <a:solidFill>
                   <a:srgbClr val="14161C"/>
                 </a:solidFill>

</xml_diff>

<commit_message>
Slides: sd-13 code text in Be Vietnam Pro, shape labels at 34 px
Co-Authored-By: Claude Opus 5.5 <noreply@anthropic.com>
Claude-Session: https://claude.ai/code/session_01TQmrJYLm4GPgtXpQaEk7ey
</commit_message>
<xml_diff>
--- a/system-design-101/vi/lessons/sd-13-004/slides/sd-13-004.pptx
+++ b/system-design-101/vi/lessons/sd-13-004/slides/sd-13-004.pptx
@@ -3065,7 +3065,7 @@
               <a:buNone/>
             </a:pPr>
             <a:r>
-              <a:rPr lang="en-US" sz="2250" b="1" dirty="0" spc="0" kern="0">
+              <a:rPr lang="en-US" sz="2550" b="1" dirty="0" spc="-1" kern="0">
                 <a:solidFill>
                   <a:srgbClr val="F3EEE3"/>
                 </a:solidFill>
@@ -3076,7 +3076,7 @@
               <a:t>Bộ</a:t>
             </a:r>
             <a:r>
-              <a:rPr lang="en-US" sz="2250" b="1" dirty="0" spc="2" kern="0">
+              <a:rPr lang="en-US" sz="2550" b="1" dirty="0" spc="1" kern="0">
                 <a:solidFill>
                   <a:srgbClr val="F3EEE3"/>
                 </a:solidFill>
@@ -3084,9 +3084,20 @@
                 <a:ea typeface="Be Vietnam Pro" pitchFamily="34" charset="-122"/>
                 <a:cs typeface="Be Vietnam Pro" pitchFamily="34" charset="-120"/>
               </a:rPr>
-              <a:t> thu thập</a:t>
-            </a:r>
-            <a:endParaRPr lang="en-US" sz="2250" dirty="0"/>
+              <a:t> thu</a:t>
+            </a:r>
+            <a:r>
+              <a:rPr lang="en-US" sz="2550" b="1" dirty="0" spc="0" kern="0">
+                <a:solidFill>
+                  <a:srgbClr val="F3EEE3"/>
+                </a:solidFill>
+                <a:latin typeface="Be Vietnam Pro" pitchFamily="34" charset="0"/>
+                <a:ea typeface="Be Vietnam Pro" pitchFamily="34" charset="-122"/>
+                <a:cs typeface="Be Vietnam Pro" pitchFamily="34" charset="-120"/>
+              </a:rPr>
+              <a:t> thập</a:t>
+            </a:r>
+            <a:endParaRPr lang="en-US" sz="2550" dirty="0"/>
           </a:p>
         </p:txBody>
       </p:sp>
@@ -3144,7 +3155,7 @@
               <a:buNone/>
             </a:pPr>
             <a:r>
-              <a:rPr lang="en-US" sz="2250" b="1" dirty="0" spc="4" kern="0">
+              <a:rPr lang="en-US" sz="2550" b="1" dirty="0" spc="0" kern="0">
                 <a:solidFill>
                   <a:srgbClr val="14161C"/>
                 </a:solidFill>
@@ -3155,7 +3166,7 @@
               <a:t>Dịch</a:t>
             </a:r>
             <a:r>
-              <a:rPr lang="en-US" sz="2250" b="1" dirty="0" spc="2" kern="0">
+              <a:rPr lang="en-US" sz="2550" b="1" dirty="0" spc="-1" kern="0">
                 <a:solidFill>
                   <a:srgbClr val="14161C"/>
                 </a:solidFill>
@@ -3165,7 +3176,7 @@
               </a:rPr>
               <a:t> vụ</a:t>
             </a:r>
-            <a:endParaRPr lang="en-US" sz="2250" dirty="0"/>
+            <a:endParaRPr lang="en-US" sz="2550" dirty="0"/>
           </a:p>
         </p:txBody>
       </p:sp>
@@ -3380,7 +3391,7 @@
               <a:buNone/>
             </a:pPr>
             <a:r>
-              <a:rPr lang="en-US" sz="2250" b="1" dirty="0" spc="4" kern="0">
+              <a:rPr lang="en-US" sz="2550" b="1" dirty="0" spc="0" kern="0">
                 <a:solidFill>
                   <a:srgbClr val="14161C"/>
                 </a:solidFill>
@@ -3391,7 +3402,7 @@
               <a:t>Dịch</a:t>
             </a:r>
             <a:r>
-              <a:rPr lang="en-US" sz="2250" b="1" dirty="0" spc="2" kern="0">
+              <a:rPr lang="en-US" sz="2550" b="1" dirty="0" spc="-1" kern="0">
                 <a:solidFill>
                   <a:srgbClr val="14161C"/>
                 </a:solidFill>
@@ -3401,7 +3412,7 @@
               </a:rPr>
               <a:t> vụ</a:t>
             </a:r>
-            <a:endParaRPr lang="en-US" sz="2250" dirty="0"/>
+            <a:endParaRPr lang="en-US" sz="2550" dirty="0"/>
           </a:p>
         </p:txBody>
       </p:sp>
@@ -3459,7 +3470,7 @@
               <a:buNone/>
             </a:pPr>
             <a:r>
-              <a:rPr lang="en-US" sz="2250" b="1" dirty="0" spc="0" kern="0">
+              <a:rPr lang="en-US" sz="2550" b="1" dirty="0" spc="-1" kern="0">
                 <a:solidFill>
                   <a:srgbClr val="F3EEE3"/>
                 </a:solidFill>
@@ -3470,7 +3481,7 @@
               <a:t>Bộ</a:t>
             </a:r>
             <a:r>
-              <a:rPr lang="en-US" sz="2250" b="1" dirty="0" spc="2" kern="0">
+              <a:rPr lang="en-US" sz="2550" b="1" dirty="0" spc="1" kern="0">
                 <a:solidFill>
                   <a:srgbClr val="F3EEE3"/>
                 </a:solidFill>
@@ -3478,9 +3489,20 @@
                 <a:ea typeface="Be Vietnam Pro" pitchFamily="34" charset="-122"/>
                 <a:cs typeface="Be Vietnam Pro" pitchFamily="34" charset="-120"/>
               </a:rPr>
-              <a:t> thu thập</a:t>
-            </a:r>
-            <a:endParaRPr lang="en-US" sz="2250" dirty="0"/>
+              <a:t> thu</a:t>
+            </a:r>
+            <a:r>
+              <a:rPr lang="en-US" sz="2550" b="1" dirty="0" spc="0" kern="0">
+                <a:solidFill>
+                  <a:srgbClr val="F3EEE3"/>
+                </a:solidFill>
+                <a:latin typeface="Be Vietnam Pro" pitchFamily="34" charset="0"/>
+                <a:ea typeface="Be Vietnam Pro" pitchFamily="34" charset="-122"/>
+                <a:cs typeface="Be Vietnam Pro" pitchFamily="34" charset="-120"/>
+              </a:rPr>
+              <a:t> thập</a:t>
+            </a:r>
+            <a:endParaRPr lang="en-US" sz="2550" dirty="0"/>
           </a:p>
         </p:txBody>
       </p:sp>
@@ -3618,7 +3640,7 @@
               <a:buNone/>
             </a:pPr>
             <a:r>
-              <a:rPr lang="en-US" sz="2400" b="1" dirty="0" spc="-9" kern="0">
+              <a:rPr lang="en-US" sz="2550" b="1" dirty="0" spc="-7" kern="0">
                 <a:solidFill>
                   <a:srgbClr val="14161C"/>
                 </a:solidFill>
@@ -3629,7 +3651,7 @@
               <a:t>Không</a:t>
             </a:r>
             <a:r>
-              <a:rPr lang="en-US" sz="2400" b="1" dirty="0" spc="-4" kern="0">
+              <a:rPr lang="en-US" sz="2550" b="1" dirty="0" spc="-4" kern="0">
                 <a:solidFill>
                   <a:srgbClr val="14161C"/>
                 </a:solidFill>
@@ -3640,7 +3662,7 @@
               <a:t> có</a:t>
             </a:r>
             <a:r>
-              <a:rPr lang="en-US" sz="2400" b="1" dirty="0" spc="0" kern="0">
+              <a:rPr lang="en-US" sz="2550" b="1" dirty="0" spc="2" kern="0">
                 <a:solidFill>
                   <a:srgbClr val="14161C"/>
                 </a:solidFill>
@@ -3651,18 +3673,40 @@
               <a:t> cách</a:t>
             </a:r>
             <a:r>
-              <a:rPr lang="en-US" sz="2400" b="1" dirty="0" spc="-3" kern="0">
-                <a:solidFill>
-                  <a:srgbClr val="14161C"/>
-                </a:solidFill>
-                <a:latin typeface="Be Vietnam Pro" pitchFamily="34" charset="0"/>
-                <a:ea typeface="Be Vietnam Pro" pitchFamily="34" charset="-122"/>
-                <a:cs typeface="Be Vietnam Pro" pitchFamily="34" charset="-120"/>
-              </a:rPr>
-              <a:t> đúng cho mọi</a:t>
-            </a:r>
-            <a:r>
-              <a:rPr lang="en-US" sz="2400" b="1" dirty="0" spc="5" kern="0">
+              <a:rPr lang="en-US" sz="2550" b="1" dirty="0" spc="-4" kern="0">
+                <a:solidFill>
+                  <a:srgbClr val="14161C"/>
+                </a:solidFill>
+                <a:latin typeface="Be Vietnam Pro" pitchFamily="34" charset="0"/>
+                <a:ea typeface="Be Vietnam Pro" pitchFamily="34" charset="-122"/>
+                <a:cs typeface="Be Vietnam Pro" pitchFamily="34" charset="-120"/>
+              </a:rPr>
+              <a:t> đúng</a:t>
+            </a:r>
+            <a:r>
+              <a:rPr lang="en-US" sz="2550" b="1" dirty="0" spc="-2" kern="0">
+                <a:solidFill>
+                  <a:srgbClr val="14161C"/>
+                </a:solidFill>
+                <a:latin typeface="Be Vietnam Pro" pitchFamily="34" charset="0"/>
+                <a:ea typeface="Be Vietnam Pro" pitchFamily="34" charset="-122"/>
+                <a:cs typeface="Be Vietnam Pro" pitchFamily="34" charset="-120"/>
+              </a:rPr>
+              <a:t> cho</a:t>
+            </a:r>
+            <a:r>
+              <a:rPr lang="en-US" sz="2550" b="1" dirty="0" spc="-3" kern="0">
+                <a:solidFill>
+                  <a:srgbClr val="14161C"/>
+                </a:solidFill>
+                <a:latin typeface="Be Vietnam Pro" pitchFamily="34" charset="0"/>
+                <a:ea typeface="Be Vietnam Pro" pitchFamily="34" charset="-122"/>
+                <a:cs typeface="Be Vietnam Pro" pitchFamily="34" charset="-120"/>
+              </a:rPr>
+              <a:t> mọi</a:t>
+            </a:r>
+            <a:r>
+              <a:rPr lang="en-US" sz="2550" b="1" dirty="0" spc="6" kern="0">
                 <a:solidFill>
                   <a:srgbClr val="14161C"/>
                 </a:solidFill>
@@ -3673,7 +3717,7 @@
               <a:t> trường</a:t>
             </a:r>
             <a:r>
-              <a:rPr lang="en-US" sz="2400" b="1" dirty="0" spc="-1" kern="0">
+              <a:rPr lang="en-US" sz="2550" b="1" dirty="0" spc="-1" kern="0">
                 <a:solidFill>
                   <a:srgbClr val="14161C"/>
                 </a:solidFill>
@@ -3683,19 +3727,25 @@
               </a:rPr>
               <a:t> hợp.</a:t>
             </a:r>
-            <a:r>
-              <a:rPr lang="en-US" sz="2400" b="1" dirty="0" spc="-7" kern="0">
-                <a:solidFill>
-                  <a:srgbClr val="14161C"/>
-                </a:solidFill>
-                <a:latin typeface="Be Vietnam Pro" pitchFamily="34" charset="0"/>
-                <a:ea typeface="Be Vietnam Pro" pitchFamily="34" charset="-122"/>
-                <a:cs typeface="Be Vietnam Pro" pitchFamily="34" charset="-120"/>
-              </a:rPr>
-              <a:t> Hệ</a:t>
-            </a:r>
-            <a:r>
-              <a:rPr lang="en-US" sz="2400" b="1" dirty="0" spc="-8" kern="0">
+            <a:endParaRPr lang="en-US" sz="2550" dirty="0"/>
+          </a:p>
+          <a:p>
+            <a:pPr algn="ctr" indent="0" marL="0">
+              <a:buNone/>
+            </a:pPr>
+            <a:r>
+              <a:rPr lang="en-US" sz="2550" b="1" dirty="0" spc="-5" kern="0">
+                <a:solidFill>
+                  <a:srgbClr val="14161C"/>
+                </a:solidFill>
+                <a:latin typeface="Be Vietnam Pro" pitchFamily="34" charset="0"/>
+                <a:ea typeface="Be Vietnam Pro" pitchFamily="34" charset="-122"/>
+                <a:cs typeface="Be Vietnam Pro" pitchFamily="34" charset="-120"/>
+              </a:rPr>
+              <a:t>Hệ</a:t>
+            </a:r>
+            <a:r>
+              <a:rPr lang="en-US" sz="2550" b="1" dirty="0" spc="-6" kern="0">
                 <a:solidFill>
                   <a:srgbClr val="14161C"/>
                 </a:solidFill>
@@ -3706,7 +3756,7 @@
               <a:t> thống</a:t>
             </a:r>
             <a:r>
-              <a:rPr lang="en-US" sz="2400" b="1" dirty="0" spc="-5" kern="0">
+              <a:rPr lang="en-US" sz="2550" b="1" dirty="0" spc="-5" kern="0">
                 <a:solidFill>
                   <a:srgbClr val="14161C"/>
                 </a:solidFill>
@@ -3717,7 +3767,7 @@
               <a:t> thật</a:t>
             </a:r>
             <a:r>
-              <a:rPr lang="en-US" sz="2400" b="1" dirty="0" spc="4" kern="0">
+              <a:rPr lang="en-US" sz="2550" b="1" dirty="0" spc="7" kern="0">
                 <a:solidFill>
                   <a:srgbClr val="14161C"/>
                 </a:solidFill>
@@ -3728,7 +3778,7 @@
               <a:t> thường</a:t>
             </a:r>
             <a:r>
-              <a:rPr lang="en-US" sz="2400" b="1" dirty="0" spc="-3" kern="0">
+              <a:rPr lang="en-US" sz="2550" b="1" dirty="0" spc="-2" kern="0">
                 <a:solidFill>
                   <a:srgbClr val="14161C"/>
                 </a:solidFill>
@@ -3739,7 +3789,7 @@
               <a:t> dùng</a:t>
             </a:r>
             <a:r>
-              <a:rPr lang="en-US" sz="2400" b="1" dirty="0" spc="-4" kern="0">
+              <a:rPr lang="en-US" sz="2550" b="1" dirty="0" spc="-4" kern="0">
                 <a:solidFill>
                   <a:srgbClr val="14161C"/>
                 </a:solidFill>
@@ -3750,7 +3800,7 @@
               <a:t> cả</a:t>
             </a:r>
             <a:r>
-              <a:rPr lang="en-US" sz="2400" b="1" dirty="0" spc="0" kern="0">
+              <a:rPr lang="en-US" sz="2550" b="1" dirty="0" spc="1" kern="0">
                 <a:solidFill>
                   <a:srgbClr val="14161C"/>
                 </a:solidFill>
@@ -3760,7 +3810,7 @@
               </a:rPr>
               <a:t> hai.</a:t>
             </a:r>
-            <a:endParaRPr lang="en-US" sz="2400" dirty="0"/>
+            <a:endParaRPr lang="en-US" sz="2550" dirty="0"/>
           </a:p>
         </p:txBody>
       </p:sp>
@@ -5968,7 +6018,7 @@
               <a:buNone/>
             </a:pPr>
             <a:r>
-              <a:rPr lang="en-US" sz="2250" b="1" dirty="0" spc="-68" kern="0">
+              <a:rPr lang="en-US" sz="2550" b="1" dirty="0" spc="-79" kern="0">
                 <a:solidFill>
                   <a:srgbClr val="FFB454"/>
                 </a:solidFill>
@@ -5979,7 +6029,7 @@
               <a:t>Tác</a:t>
             </a:r>
             <a:r>
-              <a:rPr lang="en-US" sz="2250" b="1" dirty="0" spc="2" kern="0">
+              <a:rPr lang="en-US" sz="2550" b="1" dirty="0" spc="-2" kern="0">
                 <a:solidFill>
                   <a:srgbClr val="FFB454"/>
                 </a:solidFill>
@@ -5990,7 +6040,7 @@
               <a:t> vụ</a:t>
             </a:r>
             <a:r>
-              <a:rPr lang="en-US" sz="2250" b="1" dirty="0" spc="-4" kern="0">
+              <a:rPr lang="en-US" sz="2550" b="1" dirty="0" spc="-6" kern="0">
                 <a:solidFill>
                   <a:srgbClr val="FFB454"/>
                 </a:solidFill>
@@ -6000,7 +6050,7 @@
               </a:rPr>
               <a:t> batch</a:t>
             </a:r>
-            <a:endParaRPr lang="en-US" sz="2250" dirty="0"/>
+            <a:endParaRPr lang="en-US" sz="2550" dirty="0"/>
           </a:p>
         </p:txBody>
       </p:sp>
@@ -6033,7 +6083,7 @@
               <a:buNone/>
             </a:pPr>
             <a:r>
-              <a:rPr lang="en-US" sz="2250" b="1" dirty="0" spc="-19" kern="0">
+              <a:rPr lang="en-US" sz="2550" b="1" dirty="0" spc="-23" kern="0">
                 <a:solidFill>
                   <a:srgbClr val="14161C"/>
                 </a:solidFill>
@@ -6043,7 +6093,7 @@
               </a:rPr>
               <a:t>Pushgateway</a:t>
             </a:r>
-            <a:endParaRPr lang="en-US" sz="2250" dirty="0"/>
+            <a:endParaRPr lang="en-US" sz="2550" dirty="0"/>
           </a:p>
         </p:txBody>
       </p:sp>
@@ -6081,7 +6131,7 @@
               <a:buNone/>
             </a:pPr>
             <a:r>
-              <a:rPr lang="en-US" sz="2250" b="1" dirty="0" spc="-9" kern="0">
+              <a:rPr lang="en-US" sz="2550" b="1" dirty="0" spc="-14" kern="0">
                 <a:solidFill>
                   <a:srgbClr val="F3EEE3"/>
                 </a:solidFill>
@@ -6091,7 +6141,7 @@
               </a:rPr>
               <a:t>Prometheus</a:t>
             </a:r>
-            <a:endParaRPr lang="en-US" sz="2250" dirty="0"/>
+            <a:endParaRPr lang="en-US" sz="2550" dirty="0"/>
           </a:p>
         </p:txBody>
       </p:sp>
@@ -6421,7 +6471,7 @@
               <a:buNone/>
             </a:pPr>
             <a:r>
-              <a:rPr lang="en-US" sz="2400" b="1" dirty="0" spc="-42" kern="0">
+              <a:rPr lang="en-US" sz="2550" b="1" dirty="0" spc="-44" kern="0">
                 <a:solidFill>
                   <a:srgbClr val="FFB454"/>
                 </a:solidFill>
@@ -6432,7 +6482,7 @@
               <a:t>Kết</a:t>
             </a:r>
             <a:r>
-              <a:rPr lang="en-US" sz="2400" b="1" dirty="0" spc="2" kern="0">
+              <a:rPr lang="en-US" sz="2550" b="1" dirty="0" spc="1" kern="0">
                 <a:solidFill>
                   <a:srgbClr val="FFB454"/>
                 </a:solidFill>
@@ -6443,7 +6493,7 @@
               <a:t> quả</a:t>
             </a:r>
             <a:r>
-              <a:rPr lang="en-US" sz="2400" b="1" dirty="0" spc="-7" kern="0">
+              <a:rPr lang="en-US" sz="2550" b="1" dirty="0" spc="-6" kern="0">
                 <a:solidFill>
                   <a:srgbClr val="FFB454"/>
                 </a:solidFill>
@@ -6454,7 +6504,7 @@
               <a:t> còn</a:t>
             </a:r>
             <a:r>
-              <a:rPr lang="en-US" sz="2400" b="1" dirty="0" spc="0" kern="0">
+              <a:rPr lang="en-US" sz="2550" b="1" dirty="0" spc="-1" kern="0">
                 <a:solidFill>
                   <a:srgbClr val="FFB454"/>
                 </a:solidFill>
@@ -6465,7 +6515,7 @@
               <a:t> lại</a:t>
             </a:r>
             <a:r>
-              <a:rPr lang="en-US" sz="2400" b="1" dirty="0" spc="3" kern="0">
+              <a:rPr lang="en-US" sz="2550" b="1" dirty="0" spc="0" kern="0">
                 <a:solidFill>
                   <a:srgbClr val="FFB454"/>
                 </a:solidFill>
@@ -6476,7 +6526,7 @@
               <a:t> sau</a:t>
             </a:r>
             <a:r>
-              <a:rPr lang="en-US" sz="2400" b="1" dirty="0" spc="-1" kern="0">
+              <a:rPr lang="en-US" sz="2550" b="1" dirty="0" spc="2" kern="0">
                 <a:solidFill>
                   <a:srgbClr val="FFB454"/>
                 </a:solidFill>
@@ -6487,7 +6537,7 @@
               <a:t> khi</a:t>
             </a:r>
             <a:r>
-              <a:rPr lang="en-US" sz="2400" b="1" dirty="0" spc="0" kern="0">
+              <a:rPr lang="en-US" sz="2550" b="1" dirty="0" spc="1" kern="0">
                 <a:solidFill>
                   <a:srgbClr val="FFB454"/>
                 </a:solidFill>
@@ -6498,7 +6548,7 @@
               <a:t> tác</a:t>
             </a:r>
             <a:r>
-              <a:rPr lang="en-US" sz="2400" b="1" dirty="0" spc="2" kern="0">
+              <a:rPr lang="en-US" sz="2550" b="1" dirty="0" spc="-1" kern="0">
                 <a:solidFill>
                   <a:srgbClr val="FFB454"/>
                 </a:solidFill>
@@ -6509,7 +6559,7 @@
               <a:t> vụ</a:t>
             </a:r>
             <a:r>
-              <a:rPr lang="en-US" sz="2400" b="1" dirty="0" spc="-30" kern="0">
+              <a:rPr lang="en-US" sz="2550" b="1" dirty="0" spc="-29" kern="0">
                 <a:solidFill>
                   <a:srgbClr val="FFB454"/>
                 </a:solidFill>
@@ -6520,7 +6570,7 @@
               <a:t> kết</a:t>
             </a:r>
             <a:r>
-              <a:rPr lang="en-US" sz="2400" b="1" dirty="0" spc="1" kern="0">
+              <a:rPr lang="en-US" sz="2550" b="1" dirty="0" spc="1" kern="0">
                 <a:solidFill>
                   <a:srgbClr val="FFB454"/>
                 </a:solidFill>
@@ -6530,7 +6580,7 @@
               </a:rPr>
               <a:t> thúc.</a:t>
             </a:r>
-            <a:endParaRPr lang="en-US" sz="2400" dirty="0"/>
+            <a:endParaRPr lang="en-US" sz="2550" dirty="0"/>
           </a:p>
         </p:txBody>
       </p:sp>
@@ -7282,7 +7332,7 @@
               <a:buNone/>
             </a:pPr>
             <a:r>
-              <a:rPr lang="en-US" sz="2250" b="1" dirty="0" spc="4" kern="0">
+              <a:rPr lang="en-US" sz="2550" b="1" dirty="0" kern="0">
                 <a:solidFill>
                   <a:srgbClr val="14161C"/>
                 </a:solidFill>
@@ -7292,7 +7342,7 @@
               </a:rPr>
               <a:t>Đích</a:t>
             </a:r>
-            <a:endParaRPr lang="en-US" sz="2250" dirty="0"/>
+            <a:endParaRPr lang="en-US" sz="2550" dirty="0"/>
           </a:p>
         </p:txBody>
       </p:sp>
@@ -7325,7 +7375,7 @@
               <a:buNone/>
             </a:pPr>
             <a:r>
-              <a:rPr lang="en-US" sz="2250" b="1" dirty="0" spc="4" kern="0">
+              <a:rPr lang="en-US" sz="2550" b="1" dirty="0" kern="0">
                 <a:solidFill>
                   <a:srgbClr val="14161C"/>
                 </a:solidFill>
@@ -7335,7 +7385,7 @@
               </a:rPr>
               <a:t>Đích</a:t>
             </a:r>
-            <a:endParaRPr lang="en-US" sz="2250" dirty="0"/>
+            <a:endParaRPr lang="en-US" sz="2550" dirty="0"/>
           </a:p>
         </p:txBody>
       </p:sp>
@@ -7658,7 +7708,7 @@
               <a:buNone/>
             </a:pPr>
             <a:r>
-              <a:rPr lang="en-US" sz="2400" b="1" dirty="0" spc="-3" kern="0">
+              <a:rPr lang="en-US" sz="2550" b="1" dirty="0" spc="-4" kern="0">
                 <a:solidFill>
                   <a:srgbClr val="F3EEE3"/>
                 </a:solidFill>
@@ -7669,7 +7719,7 @@
               <a:t>Kho</a:t>
             </a:r>
             <a:r>
-              <a:rPr lang="en-US" sz="2400" b="1" dirty="0" spc="-2" kern="0">
+              <a:rPr lang="en-US" sz="2550" b="1" dirty="0" spc="-2" kern="0">
                 <a:solidFill>
                   <a:srgbClr val="F3EEE3"/>
                 </a:solidFill>
@@ -7679,7 +7729,7 @@
               </a:rPr>
               <a:t> trung tâm</a:t>
             </a:r>
-            <a:endParaRPr lang="en-US" sz="2400" dirty="0"/>
+            <a:endParaRPr lang="en-US" sz="2550" dirty="0"/>
           </a:p>
         </p:txBody>
       </p:sp>

</xml_diff>